<commit_message>
docs: correct TF/MC routing in editable architecture diagram
- 'sufficient -> Answer Agent' (dropped the misleading '/ MC' label)
- insufficient -> Local-Completion (gap-local); then external retrieval (agent 6)
- TF branch: agent6 -> Court (7) -> Answer (8)   [Court is TF-only]
- MC branch: agent6 -> bypass Court, routed below it -> Answer (8)
Court title now marked '(TF only)' to make the type-specific defense explicit.
</commit_message>
<xml_diff>
--- a/slides/ADRD_MultiAgent_architecture_editable.pptx
+++ b/slides/ADRD_MultiAgent_architecture_editable.pptx
@@ -3097,7 +3097,7 @@
         <p:spPr>
           <a:xfrm>
             <a:off x="365760" y="109728"/>
-            <a:ext cx="11430000" cy="502920"/>
+            <a:ext cx="11430000" cy="457200"/>
           </a:xfrm>
           <a:prstGeom prst="rect">
             <a:avLst/>
@@ -3111,7 +3111,7 @@
           <a:lstStyle/>
           <a:p>
             <a:r>
-              <a:rPr sz="2200" b="1">
+              <a:rPr sz="2100" b="1">
                 <a:solidFill>
                   <a:srgbClr val="1F3B57"/>
                 </a:solidFill>
@@ -3129,8 +3129,8 @@
         </p:nvSpPr>
         <p:spPr>
           <a:xfrm>
-            <a:off x="365760" y="685800"/>
-            <a:ext cx="11457432" cy="411480"/>
+            <a:off x="365760" y="658368"/>
+            <a:ext cx="11457432" cy="384048"/>
           </a:xfrm>
           <a:prstGeom prst="roundRect">
             <a:avLst/>
@@ -3165,12 +3165,12 @@
           <a:p>
             <a:pPr algn="ctr"/>
             <a:r>
-              <a:rPr sz="1000" b="1">
+              <a:rPr sz="950" b="1">
                 <a:solidFill>
                   <a:srgbClr val="000000"/>
                 </a:solidFill>
               </a:rPr>
-              <a:t>① Orchestrator Agent — coordinates every step via the shared Blackboard (deterministic loop; no framework)</a:t>
+              <a:t>① Orchestrator Agent — coordinates every step via the shared Blackboard (deterministic loop)</a:t>
             </a:r>
           </a:p>
         </p:txBody>
@@ -3183,8 +3183,8 @@
         </p:nvSpPr>
         <p:spPr>
           <a:xfrm>
-            <a:off x="365760" y="1417320"/>
-            <a:ext cx="1051560" cy="777240"/>
+            <a:off x="365760" y="1371600"/>
+            <a:ext cx="1005840" cy="731520"/>
           </a:xfrm>
           <a:prstGeom prst="roundRect">
             <a:avLst/>
@@ -3219,7 +3219,7 @@
           <a:p>
             <a:pPr algn="ctr"/>
             <a:r>
-              <a:rPr sz="1000" b="1">
+              <a:rPr sz="950" b="1">
                 <a:solidFill>
                   <a:srgbClr val="000000"/>
                 </a:solidFill>
@@ -3237,8 +3237,8 @@
         </p:nvSpPr>
         <p:spPr>
           <a:xfrm>
-            <a:off x="1600200" y="1417320"/>
-            <a:ext cx="1691640" cy="777240"/>
+            <a:off x="1554480" y="1371600"/>
+            <a:ext cx="1645920" cy="731520"/>
           </a:xfrm>
           <a:prstGeom prst="roundRect">
             <a:avLst/>
@@ -3302,8 +3302,8 @@
         </p:nvSpPr>
         <p:spPr>
           <a:xfrm>
-            <a:off x="3474720" y="1417320"/>
-            <a:ext cx="1965960" cy="777240"/>
+            <a:off x="3383280" y="1371600"/>
+            <a:ext cx="1828800" cy="731520"/>
           </a:xfrm>
           <a:prstGeom prst="roundRect">
             <a:avLst/>
@@ -3354,7 +3354,7 @@
                   <a:srgbClr val="000000"/>
                 </a:solidFill>
               </a:rPr>
-              <a:t>BM25+dense · rerank · noise-filter</a:t>
+              <a:t>BM25+dense · rerank · noise</a:t>
             </a:r>
           </a:p>
         </p:txBody>
@@ -3367,8 +3367,8 @@
         </p:nvSpPr>
         <p:spPr>
           <a:xfrm>
-            <a:off x="5623560" y="1417320"/>
-            <a:ext cx="1965960" cy="777240"/>
+            <a:off x="5394960" y="1371600"/>
+            <a:ext cx="1920240" cy="731520"/>
           </a:xfrm>
           <a:prstGeom prst="roundRect">
             <a:avLst/>
@@ -3408,7 +3408,7 @@
                   <a:srgbClr val="000000"/>
                 </a:solidFill>
               </a:rPr>
-              <a:t>④ Sufficiency Panel (ItV)</a:t>
+              <a:t>④ Sufficiency (ItV)</a:t>
             </a:r>
           </a:p>
           <a:p>
@@ -3432,8 +3432,8 @@
         </p:nvSpPr>
         <p:spPr>
           <a:xfrm>
-            <a:off x="5623560" y="2468880"/>
-            <a:ext cx="1965960" cy="640080"/>
+            <a:off x="5394960" y="2377440"/>
+            <a:ext cx="1920240" cy="640080"/>
           </a:xfrm>
           <a:prstGeom prst="roundRect">
             <a:avLst/>
@@ -3468,7 +3468,7 @@
           <a:p>
             <a:pPr algn="ctr"/>
             <a:r>
-              <a:rPr sz="900" b="0">
+              <a:rPr sz="900" b="1">
                 <a:solidFill>
                   <a:srgbClr val="000000"/>
                 </a:solidFill>
@@ -3497,7 +3497,7 @@
         </p:nvCxnSpPr>
         <p:spPr>
           <a:xfrm>
-            <a:off x="1417320" y="1801368"/>
+            <a:off x="1371600" y="1737360"/>
             <a:ext cx="182880" cy="0"/>
           </a:xfrm>
           <a:prstGeom prst="line">
@@ -3534,7 +3534,7 @@
         </p:nvCxnSpPr>
         <p:spPr>
           <a:xfrm>
-            <a:off x="3291840" y="1801368"/>
+            <a:off x="3200400" y="1737360"/>
             <a:ext cx="182880" cy="0"/>
           </a:xfrm>
           <a:prstGeom prst="line">
@@ -3571,7 +3571,7 @@
         </p:nvCxnSpPr>
         <p:spPr>
           <a:xfrm>
-            <a:off x="5440680" y="1801368"/>
+            <a:off x="5212080" y="1737360"/>
             <a:ext cx="182880" cy="0"/>
           </a:xfrm>
           <a:prstGeom prst="line">
@@ -3608,7 +3608,7 @@
         </p:nvCxnSpPr>
         <p:spPr>
           <a:xfrm>
-            <a:off x="6601968" y="2194560"/>
+            <a:off x="6355080" y="2103120"/>
             <a:ext cx="0" cy="274320"/>
           </a:xfrm>
           <a:prstGeom prst="line">
@@ -3645,8 +3645,8 @@
         </p:nvSpPr>
         <p:spPr>
           <a:xfrm>
-            <a:off x="6675120" y="2212848"/>
-            <a:ext cx="2011680" cy="274320"/>
+            <a:off x="6446520" y="2148840"/>
+            <a:ext cx="2194560" cy="274320"/>
           </a:xfrm>
           <a:prstGeom prst="rect">
             <a:avLst/>
@@ -3679,7 +3679,7 @@
         <p:spPr>
           <a:xfrm>
             <a:off x="365760" y="3611880"/>
-            <a:ext cx="2514600" cy="1371600"/>
+            <a:ext cx="2651760" cy="914400"/>
           </a:xfrm>
           <a:prstGeom prst="roundRect">
             <a:avLst/>
@@ -3714,7 +3714,7 @@
           <a:p>
             <a:pPr algn="ctr"/>
             <a:r>
-              <a:rPr sz="950" b="1">
+              <a:rPr sz="900" b="1">
                 <a:solidFill>
                   <a:srgbClr val="000000"/>
                 </a:solidFill>
@@ -3725,7 +3725,7 @@
           <a:p>
             <a:pPr algn="ctr"/>
             <a:r>
-              <a:rPr sz="800" b="0">
+              <a:rPr sz="750" b="0">
                 <a:solidFill>
                   <a:srgbClr val="000000"/>
                 </a:solidFill>
@@ -3736,7 +3736,7 @@
           <a:p>
             <a:pPr algn="ctr"/>
             <a:r>
-              <a:rPr sz="800" b="0">
+              <a:rPr sz="750" b="0">
                 <a:solidFill>
                   <a:srgbClr val="000000"/>
                 </a:solidFill>
@@ -3754,8 +3754,8 @@
         </p:nvSpPr>
         <p:spPr>
           <a:xfrm>
-            <a:off x="3108960" y="3383280"/>
-            <a:ext cx="4160520" cy="1965960"/>
+            <a:off x="3246120" y="3383280"/>
+            <a:ext cx="3977639" cy="1874519"/>
           </a:xfrm>
           <a:prstGeom prst="roundRect">
             <a:avLst/>
@@ -3808,8 +3808,8 @@
         </p:nvSpPr>
         <p:spPr>
           <a:xfrm>
-            <a:off x="3108960" y="3419856"/>
-            <a:ext cx="4160520" cy="274320"/>
+            <a:off x="3246120" y="3410712"/>
+            <a:ext cx="3977639" cy="256032"/>
           </a:xfrm>
           <a:prstGeom prst="rect">
             <a:avLst/>
@@ -3824,12 +3824,12 @@
           <a:p>
             <a:pPr algn="ctr"/>
             <a:r>
-              <a:rPr sz="1000" b="1">
+              <a:rPr sz="950" b="1">
                 <a:solidFill>
                   <a:srgbClr val="B45F06"/>
                 </a:solidFill>
               </a:rPr>
-              <a:t>⑦ Heterogeneous Verification Court</a:t>
+              <a:t>⑦ Heterogeneous Verification Court (TF only)</a:t>
             </a:r>
           </a:p>
         </p:txBody>
@@ -3842,8 +3842,8 @@
         </p:nvSpPr>
         <p:spPr>
           <a:xfrm>
-            <a:off x="3246120" y="3749039"/>
-            <a:ext cx="3886200" cy="411480"/>
+            <a:off x="3383280" y="3685032"/>
+            <a:ext cx="3703320" cy="365760"/>
           </a:xfrm>
           <a:prstGeom prst="roundRect">
             <a:avLst/>
@@ -3878,12 +3878,12 @@
           <a:p>
             <a:pPr algn="ctr"/>
             <a:r>
-              <a:rPr sz="850" b="0">
+              <a:rPr sz="830" b="0">
                 <a:solidFill>
                   <a:srgbClr val="000000"/>
                 </a:solidFill>
               </a:rPr>
-              <a:t>Entity Judge — ontology boundary (class ⊃ subtype) · single call</a:t>
+              <a:t>Entity Judge — ontology boundary · single call</a:t>
             </a:r>
           </a:p>
         </p:txBody>
@@ -3896,8 +3896,8 @@
         </p:nvSpPr>
         <p:spPr>
           <a:xfrm>
-            <a:off x="3246120" y="4206240"/>
-            <a:ext cx="3886200" cy="411480"/>
+            <a:off x="3383280" y="4078224"/>
+            <a:ext cx="3703320" cy="365760"/>
           </a:xfrm>
           <a:prstGeom prst="roundRect">
             <a:avLst/>
@@ -3932,12 +3932,12 @@
           <a:p>
             <a:pPr algn="ctr"/>
             <a:r>
-              <a:rPr sz="850" b="0">
+              <a:rPr sz="830" b="0">
                 <a:solidFill>
                   <a:srgbClr val="000000"/>
                 </a:solidFill>
               </a:rPr>
-              <a:t>Modal Judge — 'must/make' vs 'helps/may' · few-shot</a:t>
+              <a:t>Modal Judge — must/make vs helps/may · few-shot</a:t>
             </a:r>
           </a:p>
         </p:txBody>
@@ -3950,8 +3950,8 @@
         </p:nvSpPr>
         <p:spPr>
           <a:xfrm>
-            <a:off x="3246120" y="4663440"/>
-            <a:ext cx="3886200" cy="457200"/>
+            <a:off x="3383280" y="4471416"/>
+            <a:ext cx="3703320" cy="420624"/>
           </a:xfrm>
           <a:prstGeom prst="roundRect">
             <a:avLst/>
@@ -3986,23 +3986,12 @@
           <a:p>
             <a:pPr algn="ctr"/>
             <a:r>
-              <a:rPr sz="850" b="0">
+              <a:rPr sz="830" b="0">
                 <a:solidFill>
                   <a:srgbClr val="000000"/>
                 </a:solidFill>
               </a:rPr>
-              <a:t>Fact Judge — 3-vote self-consistency</a:t>
-            </a:r>
-          </a:p>
-          <a:p>
-            <a:pPr algn="ctr"/>
-            <a:r>
-              <a:rPr sz="700" b="0">
-                <a:solidFill>
-                  <a:srgbClr val="000000"/>
-                </a:solidFill>
-              </a:rPr>
-              <a:t>+ medical-ontology rule (syndrome/disease/disorder)</a:t>
+              <a:t>Fact Judge — 3-vote self-consistency + ontology rule</a:t>
             </a:r>
           </a:p>
         </p:txBody>
@@ -4015,8 +4004,8 @@
         </p:nvSpPr>
         <p:spPr>
           <a:xfrm>
-            <a:off x="3246120" y="5148072"/>
-            <a:ext cx="3886200" cy="292608"/>
+            <a:off x="3383280" y="4919472"/>
+            <a:ext cx="3703320" cy="274320"/>
           </a:xfrm>
           <a:prstGeom prst="roundRect">
             <a:avLst/>
@@ -4056,7 +4045,7 @@
                   <a:srgbClr val="000000"/>
                 </a:solidFill>
               </a:rPr>
-              <a:t>Arbiter — VETO: any red flag → INSUFFICIENT (keep baseline)</a:t>
+              <a:t>Arbiter — VETO: any red flag → INSUFFICIENT</a:t>
             </a:r>
           </a:p>
         </p:txBody>
@@ -4069,8 +4058,8 @@
         </p:nvSpPr>
         <p:spPr>
           <a:xfrm>
-            <a:off x="7589520" y="3794760"/>
-            <a:ext cx="1828800" cy="914400"/>
+            <a:off x="7589520" y="3611880"/>
+            <a:ext cx="1874519" cy="1920240"/>
           </a:xfrm>
           <a:prstGeom prst="roundRect">
             <a:avLst/>
@@ -4121,7 +4110,18 @@
                   <a:srgbClr val="000000"/>
                 </a:solidFill>
               </a:rPr>
-              <a:t>GPT-4 (frozen, grounded)</a:t>
+              <a:t>GPT-4</a:t>
+            </a:r>
+          </a:p>
+          <a:p>
+            <a:pPr algn="ctr"/>
+            <a:r>
+              <a:rPr sz="800" b="0">
+                <a:solidFill>
+                  <a:srgbClr val="000000"/>
+                </a:solidFill>
+              </a:rPr>
+              <a:t>(frozen, grounded)</a:t>
             </a:r>
           </a:p>
         </p:txBody>
@@ -4134,7 +4134,7 @@
         </p:nvSpPr>
         <p:spPr>
           <a:xfrm>
-            <a:off x="9692640" y="3886200"/>
+            <a:off x="9692640" y="4206240"/>
             <a:ext cx="1371600" cy="731520"/>
           </a:xfrm>
           <a:prstGeom prst="roundRect">
@@ -4188,15 +4188,15 @@
         </p:nvCxnSpPr>
         <p:spPr>
           <a:xfrm flipH="1">
-            <a:off x="2743200" y="2788920"/>
-            <a:ext cx="2880360" cy="822960"/>
+            <a:off x="2011680" y="3017520"/>
+            <a:ext cx="3474720" cy="594360"/>
           </a:xfrm>
           <a:prstGeom prst="line">
             <a:avLst/>
           </a:prstGeom>
           <a:ln w="19050">
             <a:solidFill>
-              <a:srgbClr val="333333"/>
+              <a:srgbClr val="674EA7"/>
             </a:solidFill>
             <a:tailEnd type="triangle" w="med" len="med"/>
           </a:ln>
@@ -4225,8 +4225,8 @@
         </p:nvSpPr>
         <p:spPr>
           <a:xfrm>
-            <a:off x="3657600" y="3063240"/>
-            <a:ext cx="2011680" cy="274320"/>
+            <a:off x="2926080" y="3063240"/>
+            <a:ext cx="2194560" cy="274320"/>
           </a:xfrm>
           <a:prstGeom prst="rect">
             <a:avLst/>
@@ -4245,7 +4245,7 @@
                   <a:srgbClr val="674EA7"/>
                 </a:solidFill>
               </a:rPr>
-              <a:t>TF: verify</a:t>
+              <a:t>external retrieval</a:t>
             </a:r>
           </a:p>
         </p:txBody>
@@ -4258,7 +4258,7 @@
         </p:nvCxnSpPr>
         <p:spPr>
           <a:xfrm>
-            <a:off x="2880360" y="4297680"/>
+            <a:off x="3017520" y="4069080"/>
             <a:ext cx="228600" cy="0"/>
           </a:xfrm>
           <a:prstGeom prst="line">
@@ -4294,16 +4294,16 @@
           <p:nvPr/>
         </p:nvCxnSpPr>
         <p:spPr>
-          <a:xfrm flipV="1">
-            <a:off x="7269480" y="4251960"/>
-            <a:ext cx="320040" cy="182880"/>
+          <a:xfrm>
+            <a:off x="7223760" y="4206240"/>
+            <a:ext cx="365760" cy="0"/>
           </a:xfrm>
           <a:prstGeom prst="line">
             <a:avLst/>
           </a:prstGeom>
           <a:ln w="19050">
             <a:solidFill>
-              <a:srgbClr val="333333"/>
+              <a:srgbClr val="38761D"/>
             </a:solidFill>
             <a:tailEnd type="triangle" w="med" len="med"/>
           </a:ln>
@@ -4332,8 +4332,8 @@
         </p:nvSpPr>
         <p:spPr>
           <a:xfrm>
-            <a:off x="6903720" y="4023360"/>
-            <a:ext cx="2011680" cy="274320"/>
+            <a:off x="6858000" y="3913632"/>
+            <a:ext cx="2194560" cy="274320"/>
           </a:xfrm>
           <a:prstGeom prst="rect">
             <a:avLst/>
@@ -4352,7 +4352,7 @@
                   <a:srgbClr val="38761D"/>
                 </a:solidFill>
               </a:rPr>
-              <a:t>override / keep</a:t>
+              <a:t>TF: override/keep</a:t>
             </a:r>
           </a:p>
         </p:txBody>
@@ -4365,17 +4365,16 @@
         </p:nvCxnSpPr>
         <p:spPr>
           <a:xfrm>
-            <a:off x="9418320" y="4251960"/>
-            <a:ext cx="274320" cy="0"/>
+            <a:off x="1691640" y="4526280"/>
+            <a:ext cx="0" cy="914400"/>
           </a:xfrm>
           <a:prstGeom prst="line">
             <a:avLst/>
           </a:prstGeom>
           <a:ln w="19050">
             <a:solidFill>
-              <a:srgbClr val="333333"/>
+              <a:srgbClr val="B45F06"/>
             </a:solidFill>
-            <a:tailEnd type="triangle" w="med" len="med"/>
           </a:ln>
           <a:effectLst/>
         </p:spPr>
@@ -4402,8 +4401,184 @@
         </p:nvCxnSpPr>
         <p:spPr>
           <a:xfrm>
-            <a:off x="7571231" y="1801368"/>
-            <a:ext cx="932689" cy="0"/>
+            <a:off x="1691640" y="5440680"/>
+            <a:ext cx="5897880" cy="0"/>
+          </a:xfrm>
+          <a:prstGeom prst="line">
+            <a:avLst/>
+          </a:prstGeom>
+          <a:ln w="19050">
+            <a:solidFill>
+              <a:srgbClr val="B45F06"/>
+            </a:solidFill>
+            <a:tailEnd type="triangle" w="med" len="med"/>
+          </a:ln>
+          <a:effectLst/>
+        </p:spPr>
+        <p:style>
+          <a:lnRef idx="2">
+            <a:schemeClr val="accent1"/>
+          </a:lnRef>
+          <a:fillRef idx="0">
+            <a:schemeClr val="accent1"/>
+          </a:fillRef>
+          <a:effectRef idx="1">
+            <a:schemeClr val="accent1"/>
+          </a:effectRef>
+          <a:fontRef idx="minor">
+            <a:schemeClr val="tx1"/>
+          </a:fontRef>
+        </p:style>
+      </p:cxnSp>
+      <p:sp>
+        <p:nvSpPr>
+          <p:cNvPr id="30" name="TextBox 29"/>
+          <p:cNvSpPr txBox="1"/>
+          <p:nvPr/>
+        </p:nvSpPr>
+        <p:spPr>
+          <a:xfrm>
+            <a:off x="3840480" y="5230368"/>
+            <a:ext cx="2194560" cy="274320"/>
+          </a:xfrm>
+          <a:prstGeom prst="rect">
+            <a:avLst/>
+          </a:prstGeom>
+          <a:noFill/>
+        </p:spPr>
+        <p:txBody>
+          <a:bodyPr wrap="none">
+            <a:spAutoFit/>
+          </a:bodyPr>
+          <a:lstStyle/>
+          <a:p>
+            <a:r>
+              <a:rPr sz="800" i="1">
+                <a:solidFill>
+                  <a:srgbClr val="B45F06"/>
+                </a:solidFill>
+              </a:rPr>
+              <a:t>MC: bypass court</a:t>
+            </a:r>
+          </a:p>
+        </p:txBody>
+      </p:sp>
+      <p:cxnSp>
+        <p:nvCxnSpPr>
+          <p:cNvPr id="31" name="Connector 30"/>
+          <p:cNvCxnSpPr/>
+          <p:nvPr/>
+        </p:nvCxnSpPr>
+        <p:spPr>
+          <a:xfrm>
+            <a:off x="7315200" y="1737360"/>
+            <a:ext cx="1188720" cy="0"/>
+          </a:xfrm>
+          <a:prstGeom prst="line">
+            <a:avLst/>
+          </a:prstGeom>
+          <a:ln w="19050">
+            <a:solidFill>
+              <a:srgbClr val="38761D"/>
+            </a:solidFill>
+          </a:ln>
+          <a:effectLst/>
+        </p:spPr>
+        <p:style>
+          <a:lnRef idx="2">
+            <a:schemeClr val="accent1"/>
+          </a:lnRef>
+          <a:fillRef idx="0">
+            <a:schemeClr val="accent1"/>
+          </a:fillRef>
+          <a:effectRef idx="1">
+            <a:schemeClr val="accent1"/>
+          </a:effectRef>
+          <a:fontRef idx="minor">
+            <a:schemeClr val="tx1"/>
+          </a:fontRef>
+        </p:style>
+      </p:cxnSp>
+      <p:cxnSp>
+        <p:nvCxnSpPr>
+          <p:cNvPr id="32" name="Connector 31"/>
+          <p:cNvCxnSpPr/>
+          <p:nvPr/>
+        </p:nvCxnSpPr>
+        <p:spPr>
+          <a:xfrm>
+            <a:off x="8503920" y="1737360"/>
+            <a:ext cx="0" cy="1874520"/>
+          </a:xfrm>
+          <a:prstGeom prst="line">
+            <a:avLst/>
+          </a:prstGeom>
+          <a:ln w="19050">
+            <a:solidFill>
+              <a:srgbClr val="38761D"/>
+            </a:solidFill>
+            <a:tailEnd type="triangle" w="med" len="med"/>
+          </a:ln>
+          <a:effectLst/>
+        </p:spPr>
+        <p:style>
+          <a:lnRef idx="2">
+            <a:schemeClr val="accent1"/>
+          </a:lnRef>
+          <a:fillRef idx="0">
+            <a:schemeClr val="accent1"/>
+          </a:fillRef>
+          <a:effectRef idx="1">
+            <a:schemeClr val="accent1"/>
+          </a:effectRef>
+          <a:fontRef idx="minor">
+            <a:schemeClr val="tx1"/>
+          </a:fontRef>
+        </p:style>
+      </p:cxnSp>
+      <p:sp>
+        <p:nvSpPr>
+          <p:cNvPr id="33" name="TextBox 32"/>
+          <p:cNvSpPr txBox="1"/>
+          <p:nvPr/>
+        </p:nvSpPr>
+        <p:spPr>
+          <a:xfrm>
+            <a:off x="7635240" y="1481328"/>
+            <a:ext cx="2194560" cy="274320"/>
+          </a:xfrm>
+          <a:prstGeom prst="rect">
+            <a:avLst/>
+          </a:prstGeom>
+          <a:noFill/>
+        </p:spPr>
+        <p:txBody>
+          <a:bodyPr wrap="none">
+            <a:spAutoFit/>
+          </a:bodyPr>
+          <a:lstStyle/>
+          <a:p>
+            <a:r>
+              <a:rPr sz="800" i="1">
+                <a:solidFill>
+                  <a:srgbClr val="38761D"/>
+                </a:solidFill>
+              </a:rPr>
+              <a:t>sufficient</a:t>
+            </a:r>
+          </a:p>
+        </p:txBody>
+      </p:sp>
+      <p:cxnSp>
+        <p:nvCxnSpPr>
+          <p:cNvPr id="34" name="Connector 33"/>
+          <p:cNvCxnSpPr/>
+          <p:nvPr/>
+        </p:nvCxnSpPr>
+        <p:spPr>
+          <a:xfrm>
+            <a:off x="9464040" y="4572000"/>
+            <a:ext cx="228600" cy="0"/>
           </a:xfrm>
           <a:prstGeom prst="line">
             <a:avLst/>
@@ -4431,86 +4606,16 @@
           </a:fontRef>
         </p:style>
       </p:cxnSp>
-      <p:cxnSp>
-        <p:nvCxnSpPr>
-          <p:cNvPr id="30" name="Connector 29"/>
-          <p:cNvCxnSpPr/>
-          <p:nvPr/>
-        </p:nvCxnSpPr>
-        <p:spPr>
-          <a:xfrm>
-            <a:off x="8503920" y="1801368"/>
-            <a:ext cx="0" cy="1993392"/>
-          </a:xfrm>
-          <a:prstGeom prst="line">
-            <a:avLst/>
-          </a:prstGeom>
-          <a:ln w="19050">
-            <a:solidFill>
-              <a:srgbClr val="333333"/>
-            </a:solidFill>
-            <a:tailEnd type="triangle" w="med" len="med"/>
-          </a:ln>
-          <a:effectLst/>
-        </p:spPr>
-        <p:style>
-          <a:lnRef idx="2">
-            <a:schemeClr val="accent1"/>
-          </a:lnRef>
-          <a:fillRef idx="0">
-            <a:schemeClr val="accent1"/>
-          </a:fillRef>
-          <a:effectRef idx="1">
-            <a:schemeClr val="accent1"/>
-          </a:effectRef>
-          <a:fontRef idx="minor">
-            <a:schemeClr val="tx1"/>
-          </a:fontRef>
-        </p:style>
-      </p:cxnSp>
-      <p:sp>
-        <p:nvSpPr>
-          <p:cNvPr id="31" name="TextBox 30"/>
-          <p:cNvSpPr txBox="1"/>
-          <p:nvPr/>
-        </p:nvSpPr>
-        <p:spPr>
-          <a:xfrm>
-            <a:off x="7635240" y="1463040"/>
-            <a:ext cx="2011680" cy="274320"/>
-          </a:xfrm>
-          <a:prstGeom prst="rect">
-            <a:avLst/>
-          </a:prstGeom>
-          <a:noFill/>
-        </p:spPr>
-        <p:txBody>
-          <a:bodyPr wrap="none">
-            <a:spAutoFit/>
-          </a:bodyPr>
-          <a:lstStyle/>
-          <a:p>
-            <a:r>
-              <a:rPr sz="800" i="1">
-                <a:solidFill>
-                  <a:srgbClr val="38761D"/>
-                </a:solidFill>
-              </a:rPr>
-              <a:t>sufficient / MC</a:t>
-            </a:r>
-          </a:p>
-        </p:txBody>
-      </p:sp>
-      <p:sp>
-        <p:nvSpPr>
-          <p:cNvPr id="32" name="Rounded Rectangle 31"/>
+      <p:sp>
+        <p:nvSpPr>
+          <p:cNvPr id="35" name="Rounded Rectangle 34"/>
           <p:cNvSpPr/>
           <p:nvPr/>
         </p:nvSpPr>
         <p:spPr>
           <a:xfrm>
-            <a:off x="365760" y="5715000"/>
-            <a:ext cx="11457432" cy="566928"/>
+            <a:off x="365760" y="5806440"/>
+            <a:ext cx="11457432" cy="548640"/>
           </a:xfrm>
           <a:prstGeom prst="roundRect">
             <a:avLst/>
@@ -4545,130 +4650,16 @@
           <a:p>
             <a:pPr algn="ctr"/>
             <a:r>
-              <a:rPr sz="950" b="1">
+              <a:rPr sz="900" b="1">
                 <a:solidFill>
                   <a:srgbClr val="000000"/>
                 </a:solidFill>
               </a:rPr>
-              <a:t>Shared Blackboard    question · queries · evidence{local, web_pro, web_con} · baseline_confidence · judge_flags{entity, modal, fact} · final_decision · trace</a:t>
-            </a:r>
-          </a:p>
-        </p:txBody>
-      </p:sp>
-      <p:cxnSp>
-        <p:nvCxnSpPr>
-          <p:cNvPr id="33" name="Connector 32"/>
-          <p:cNvCxnSpPr/>
-          <p:nvPr/>
-        </p:nvCxnSpPr>
-        <p:spPr>
-          <a:xfrm>
-            <a:off x="2377440" y="5532120"/>
-            <a:ext cx="0" cy="182880"/>
-          </a:xfrm>
-          <a:prstGeom prst="line">
-            <a:avLst/>
-          </a:prstGeom>
-          <a:ln w="12700">
-            <a:prstDash val="dash"/>
-            <a:solidFill>
-              <a:srgbClr val="888888"/>
-            </a:solidFill>
-            <a:tailEnd type="triangle" w="med" len="med"/>
-          </a:ln>
-          <a:effectLst/>
-        </p:spPr>
-        <p:style>
-          <a:lnRef idx="2">
-            <a:schemeClr val="accent1"/>
-          </a:lnRef>
-          <a:fillRef idx="0">
-            <a:schemeClr val="accent1"/>
-          </a:fillRef>
-          <a:effectRef idx="1">
-            <a:schemeClr val="accent1"/>
-          </a:effectRef>
-          <a:fontRef idx="minor">
-            <a:schemeClr val="tx1"/>
-          </a:fontRef>
-        </p:style>
-      </p:cxnSp>
-      <p:cxnSp>
-        <p:nvCxnSpPr>
-          <p:cNvPr id="34" name="Connector 33"/>
-          <p:cNvCxnSpPr/>
-          <p:nvPr/>
-        </p:nvCxnSpPr>
-        <p:spPr>
-          <a:xfrm flipV="1">
-            <a:off x="2377440" y="5532120"/>
-            <a:ext cx="0" cy="182880"/>
-          </a:xfrm>
-          <a:prstGeom prst="line">
-            <a:avLst/>
-          </a:prstGeom>
-          <a:ln w="12700">
-            <a:prstDash val="dash"/>
-            <a:solidFill>
-              <a:srgbClr val="888888"/>
-            </a:solidFill>
-            <a:tailEnd type="triangle" w="med" len="med"/>
-          </a:ln>
-          <a:effectLst/>
-        </p:spPr>
-        <p:style>
-          <a:lnRef idx="2">
-            <a:schemeClr val="accent1"/>
-          </a:lnRef>
-          <a:fillRef idx="0">
-            <a:schemeClr val="accent1"/>
-          </a:fillRef>
-          <a:effectRef idx="1">
-            <a:schemeClr val="accent1"/>
-          </a:effectRef>
-          <a:fontRef idx="minor">
-            <a:schemeClr val="tx1"/>
-          </a:fontRef>
-        </p:style>
-      </p:cxnSp>
-      <p:cxnSp>
-        <p:nvCxnSpPr>
-          <p:cNvPr id="35" name="Connector 34"/>
-          <p:cNvCxnSpPr/>
-          <p:nvPr/>
-        </p:nvCxnSpPr>
-        <p:spPr>
-          <a:xfrm>
-            <a:off x="6400800" y="5532120"/>
-            <a:ext cx="0" cy="182880"/>
-          </a:xfrm>
-          <a:prstGeom prst="line">
-            <a:avLst/>
-          </a:prstGeom>
-          <a:ln w="12700">
-            <a:prstDash val="dash"/>
-            <a:solidFill>
-              <a:srgbClr val="888888"/>
-            </a:solidFill>
-            <a:tailEnd type="triangle" w="med" len="med"/>
-          </a:ln>
-          <a:effectLst/>
-        </p:spPr>
-        <p:style>
-          <a:lnRef idx="2">
-            <a:schemeClr val="accent1"/>
-          </a:lnRef>
-          <a:fillRef idx="0">
-            <a:schemeClr val="accent1"/>
-          </a:fillRef>
-          <a:effectRef idx="1">
-            <a:schemeClr val="accent1"/>
-          </a:effectRef>
-          <a:fontRef idx="minor">
-            <a:schemeClr val="tx1"/>
-          </a:fontRef>
-        </p:style>
-      </p:cxnSp>
+              <a:t>Shared Blackboard   question · queries · evidence{local, web_pro, web_con} · baseline_confidence · judge_flags{entity, modal, fact} · final_decision · trace</a:t>
+            </a:r>
+          </a:p>
+        </p:txBody>
+      </p:sp>
       <p:cxnSp>
         <p:nvCxnSpPr>
           <p:cNvPr id="36" name="Connector 35"/>
@@ -4676,19 +4667,17 @@
           <p:nvPr/>
         </p:nvCxnSpPr>
         <p:spPr>
-          <a:xfrm flipV="1">
-            <a:off x="6400800" y="5532120"/>
+          <a:xfrm>
+            <a:off x="2377440" y="5623560"/>
             <a:ext cx="0" cy="182880"/>
           </a:xfrm>
           <a:prstGeom prst="line">
             <a:avLst/>
           </a:prstGeom>
           <a:ln w="12700">
-            <a:prstDash val="dash"/>
             <a:solidFill>
               <a:srgbClr val="888888"/>
             </a:solidFill>
-            <a:tailEnd type="triangle" w="med" len="med"/>
           </a:ln>
           <a:effectLst/>
         </p:spPr>
@@ -4714,19 +4703,17 @@
           <p:nvPr/>
         </p:nvCxnSpPr>
         <p:spPr>
-          <a:xfrm>
-            <a:off x="8503920" y="5532120"/>
+          <a:xfrm flipV="1">
+            <a:off x="2377440" y="5623560"/>
             <a:ext cx="0" cy="182880"/>
           </a:xfrm>
           <a:prstGeom prst="line">
             <a:avLst/>
           </a:prstGeom>
           <a:ln w="12700">
-            <a:prstDash val="dash"/>
             <a:solidFill>
               <a:srgbClr val="888888"/>
             </a:solidFill>
-            <a:tailEnd type="triangle" w="med" len="med"/>
           </a:ln>
           <a:effectLst/>
         </p:spPr>
@@ -4752,19 +4739,17 @@
           <p:nvPr/>
         </p:nvCxnSpPr>
         <p:spPr>
-          <a:xfrm flipV="1">
-            <a:off x="8503920" y="5532120"/>
+          <a:xfrm>
+            <a:off x="6400800" y="5623560"/>
             <a:ext cx="0" cy="182880"/>
           </a:xfrm>
           <a:prstGeom prst="line">
             <a:avLst/>
           </a:prstGeom>
           <a:ln w="12700">
-            <a:prstDash val="dash"/>
             <a:solidFill>
               <a:srgbClr val="888888"/>
             </a:solidFill>
-            <a:tailEnd type="triangle" w="med" len="med"/>
           </a:ln>
           <a:effectLst/>
         </p:spPr>
@@ -4783,16 +4768,124 @@
           </a:fontRef>
         </p:style>
       </p:cxnSp>
-      <p:sp>
-        <p:nvSpPr>
-          <p:cNvPr id="39" name="TextBox 38"/>
+      <p:cxnSp>
+        <p:nvCxnSpPr>
+          <p:cNvPr id="39" name="Connector 38"/>
+          <p:cNvCxnSpPr/>
+          <p:nvPr/>
+        </p:nvCxnSpPr>
+        <p:spPr>
+          <a:xfrm flipV="1">
+            <a:off x="6400800" y="5623560"/>
+            <a:ext cx="0" cy="182880"/>
+          </a:xfrm>
+          <a:prstGeom prst="line">
+            <a:avLst/>
+          </a:prstGeom>
+          <a:ln w="12700">
+            <a:solidFill>
+              <a:srgbClr val="888888"/>
+            </a:solidFill>
+          </a:ln>
+          <a:effectLst/>
+        </p:spPr>
+        <p:style>
+          <a:lnRef idx="2">
+            <a:schemeClr val="accent1"/>
+          </a:lnRef>
+          <a:fillRef idx="0">
+            <a:schemeClr val="accent1"/>
+          </a:fillRef>
+          <a:effectRef idx="1">
+            <a:schemeClr val="accent1"/>
+          </a:effectRef>
+          <a:fontRef idx="minor">
+            <a:schemeClr val="tx1"/>
+          </a:fontRef>
+        </p:style>
+      </p:cxnSp>
+      <p:cxnSp>
+        <p:nvCxnSpPr>
+          <p:cNvPr id="40" name="Connector 39"/>
+          <p:cNvCxnSpPr/>
+          <p:nvPr/>
+        </p:nvCxnSpPr>
+        <p:spPr>
+          <a:xfrm>
+            <a:off x="8503920" y="5623560"/>
+            <a:ext cx="0" cy="182880"/>
+          </a:xfrm>
+          <a:prstGeom prst="line">
+            <a:avLst/>
+          </a:prstGeom>
+          <a:ln w="12700">
+            <a:solidFill>
+              <a:srgbClr val="888888"/>
+            </a:solidFill>
+          </a:ln>
+          <a:effectLst/>
+        </p:spPr>
+        <p:style>
+          <a:lnRef idx="2">
+            <a:schemeClr val="accent1"/>
+          </a:lnRef>
+          <a:fillRef idx="0">
+            <a:schemeClr val="accent1"/>
+          </a:fillRef>
+          <a:effectRef idx="1">
+            <a:schemeClr val="accent1"/>
+          </a:effectRef>
+          <a:fontRef idx="minor">
+            <a:schemeClr val="tx1"/>
+          </a:fontRef>
+        </p:style>
+      </p:cxnSp>
+      <p:cxnSp>
+        <p:nvCxnSpPr>
+          <p:cNvPr id="41" name="Connector 40"/>
+          <p:cNvCxnSpPr/>
+          <p:nvPr/>
+        </p:nvCxnSpPr>
+        <p:spPr>
+          <a:xfrm flipV="1">
+            <a:off x="8503920" y="5623560"/>
+            <a:ext cx="0" cy="182880"/>
+          </a:xfrm>
+          <a:prstGeom prst="line">
+            <a:avLst/>
+          </a:prstGeom>
+          <a:ln w="12700">
+            <a:solidFill>
+              <a:srgbClr val="888888"/>
+            </a:solidFill>
+          </a:ln>
+          <a:effectLst/>
+        </p:spPr>
+        <p:style>
+          <a:lnRef idx="2">
+            <a:schemeClr val="accent1"/>
+          </a:lnRef>
+          <a:fillRef idx="0">
+            <a:schemeClr val="accent1"/>
+          </a:fillRef>
+          <a:effectRef idx="1">
+            <a:schemeClr val="accent1"/>
+          </a:effectRef>
+          <a:fontRef idx="minor">
+            <a:schemeClr val="tx1"/>
+          </a:fontRef>
+        </p:style>
+      </p:cxnSp>
+      <p:sp>
+        <p:nvSpPr>
+          <p:cNvPr id="42" name="TextBox 41"/>
           <p:cNvSpPr txBox="1"/>
           <p:nvPr/>
         </p:nvSpPr>
         <p:spPr>
           <a:xfrm>
-            <a:off x="457200" y="5468112"/>
-            <a:ext cx="2011680" cy="274320"/>
+            <a:off x="457200" y="5577840"/>
+            <a:ext cx="2194560" cy="274320"/>
           </a:xfrm>
           <a:prstGeom prst="rect">
             <a:avLst/>

</xml_diff>